<commit_message>
Record Rhino MCP install and port LBM solver into Grasshopper
</commit_message>
<xml_diff>
--- a/AI in Architecture - Presentation.pptx
+++ b/AI in Architecture - Presentation.pptx
@@ -1443,7 +1443,8 @@
               <a:buNone/>
             </a:pPr>
             <a:r>
-              <a:t/>
+              <a:rPr lang="en-GB"/>
+              <a:t>Setup: https://mcneel.github.io/RhinoAI/docs/getting-started/codex/. Install Rhino-MCP-Platform using PackageManager. Restart Rhino. Run MCPConnect and choose Codex Install. Restart Codex to load the tools, then run MCPStart in Rhino. Make one torus through MCP and check that it is a valid closed solid. Actual OBS recording: 01-rhino-mcp-install.mp4. Saved model: 01-install-check.3dm. Tested with Rhino 8.36, Rhino-MCP-Platform 0.3.0 and Apple Silicon.</a:t>
             </a:r>
             <a:endParaRPr/>
           </a:p>
@@ -1839,7 +1840,8 @@
               <a:buNone/>
             </a:pPr>
             <a:r>
-              <a:t/>
+              <a:rPr lang="en-GB"/>
+              <a:t>Source: https://github.com/jviquerat/lbm, commit 64023fc76db2ddb681b2d4d24306a433e85f9555 (MIT, Jonathan Viquerat). Adapt the existing D2Q9/TRT code into a Grasshopper Python 3 tool. Replace Numba decorators with NumPy; keep the numerical routines. Rasterise closed footprints on a 160 x 64 grid. Solve 1800 steps, then move the middle block by -12 lattice units and solve again. OBS video: 05-lbm-to-grasshopper.mp4. The code, GH definition, two output models and checks are at the repo root. Both runs have finite populations and positive density. Colour shows speed relative to inlet peak; line segments show local velocity direction. This is a 2D laminar channel in lattice units. It omits vertical flow and atmospheric boundary conditions; grid convergence and physical accuracy have not been assessed.</a:t>
             </a:r>
             <a:endParaRPr/>
           </a:p>
@@ -20299,7 +20301,7 @@
               <a:buNone/>
             </a:pPr>
             <a:r>
-              <a:rPr b="0" i="0" lang="en-GB" sz="800" u="none" strike="noStrike">
+              <a:rPr lang="en-GB" sz="800">
                 <a:solidFill>
                   <a:srgbClr val="1D4ED8"/>
                 </a:solidFill>
@@ -20308,7 +20310,7 @@
                 <a:cs typeface="JetBrains Mono SemiBold"/>
                 <a:sym typeface="JetBrains Mono SemiBold"/>
               </a:rPr>
-              <a:t>SETUP GUIDE // MODEL CONTEXT PROTOCOL FOR RHINO 8 &amp; CLAUDE / CURSOR</a:t>
+              <a:t>SETUP GUIDE // RHINO 8 AND CODEX</a:t>
             </a:r>
             <a:endParaRPr b="0" i="0" sz="800" u="none" strike="noStrike">
               <a:solidFill>
@@ -20675,7 +20677,7 @@
               <a:buNone/>
             </a:pPr>
             <a:r>
-              <a:rPr b="1" i="0" lang="en-GB" sz="1200" u="none" strike="noStrike">
+              <a:rPr b="1" lang="en-GB" sz="1200">
                 <a:solidFill>
                   <a:srgbClr val="111315"/>
                 </a:solidFill>
@@ -20684,7 +20686,7 @@
                 <a:cs typeface="Space Grotesk"/>
                 <a:sym typeface="Space Grotesk"/>
               </a:rPr>
-              <a:t>Rhino 8 Prereqs</a:t>
+              <a:t>Rhino 8</a:t>
             </a:r>
             <a:endParaRPr b="1" i="0" sz="750" u="none" strike="noStrike">
               <a:solidFill>
@@ -20710,7 +20712,7 @@
               <a:buNone/>
             </a:pPr>
             <a:r>
-              <a:rPr b="0" i="0" lang="en-GB" sz="800" u="none" strike="noStrike">
+              <a:rPr lang="en-GB" sz="800">
                 <a:solidFill>
                   <a:srgbClr val="5A626A"/>
                 </a:solidFill>
@@ -20719,7 +20721,7 @@
                 <a:cs typeface="Inter"/>
                 <a:sym typeface="Inter"/>
               </a:rPr>
-              <a:t>Ensure Rhino 8 is installed with modern Python 3.8+ runtime.</a:t>
+              <a:t>Use current Rhino 8 on an Apple Silicon Mac.</a:t>
             </a:r>
             <a:endParaRPr b="1" i="0" sz="750" u="none" strike="noStrike">
               <a:solidFill>
@@ -20969,7 +20971,7 @@
                 <a:cs typeface="JetBrains Mono"/>
                 <a:sym typeface="JetBrains Mono"/>
               </a:rPr>
-              <a:t>RhinoCode</a:t>
+              <a:t>SystemInfo</a:t>
             </a:r>
             <a:endParaRPr sz="720">
               <a:solidFill>
@@ -21004,7 +21006,7 @@
                 <a:cs typeface="JetBrains Mono"/>
                 <a:sym typeface="JetBrains Mono"/>
               </a:rPr>
-              <a:t># Verify Python 3 runtime</a:t>
+              <a:t># Check the Rhino version</a:t>
             </a:r>
             <a:endParaRPr sz="720">
               <a:solidFill>
@@ -21065,7 +21067,7 @@
                 <a:cs typeface="Inter"/>
                 <a:sym typeface="Inter"/>
               </a:rPr>
-              <a:t>Required: Rhino 8.x with CPython (RhinoCode) enabled.</a:t>
+              <a:t>Tested here: Rhino 8.36 on Apple Silicon.</a:t>
             </a:r>
             <a:endParaRPr sz="720">
               <a:solidFill>
@@ -21295,7 +21297,7 @@
               <a:buNone/>
             </a:pPr>
             <a:r>
-              <a:rPr b="0" i="0" lang="en-GB" sz="800" u="none" strike="noStrike">
+              <a:rPr lang="en-GB" sz="800">
                 <a:solidFill>
                   <a:srgbClr val="5A626A"/>
                 </a:solidFill>
@@ -21304,7 +21306,7 @@
                 <a:cs typeface="Inter"/>
                 <a:sym typeface="Inter"/>
               </a:rPr>
-              <a:t>Install official RhinoAI MCP server package into Python.</a:t>
+              <a:t>Install Rhino-MCP-Platform from Rhino Package Manager.</a:t>
             </a:r>
             <a:endParaRPr b="1" i="0" sz="750" u="none" strike="noStrike">
               <a:solidFill>
@@ -21449,7 +21451,7 @@
               <a:buNone/>
             </a:pPr>
             <a:r>
-              <a:rPr b="1" i="0" lang="en-GB" sz="720" u="none" strike="noStrike">
+              <a:rPr b="1" lang="en-GB" sz="720">
                 <a:solidFill>
                   <a:srgbClr val="9CA3AF"/>
                 </a:solidFill>
@@ -21458,7 +21460,7 @@
                 <a:cs typeface="JetBrains Mono"/>
                 <a:sym typeface="JetBrains Mono"/>
               </a:rPr>
-              <a:t>TERMINAL / SHELL</a:t>
+              <a:t>RHINO COMMAND</a:t>
             </a:r>
             <a:endParaRPr b="1" i="0" sz="720" u="none" strike="noStrike">
               <a:solidFill>
@@ -21519,7 +21521,7 @@
                 <a:cs typeface="JetBrains Mono"/>
                 <a:sym typeface="JetBrains Mono"/>
               </a:rPr>
-              <a:t>pip install rhino-mcp</a:t>
+              <a:t>PackageManager</a:t>
             </a:r>
             <a:endParaRPr sz="720">
               <a:solidFill>
@@ -21554,7 +21556,7 @@
                 <a:cs typeface="JetBrains Mono"/>
                 <a:sym typeface="JetBrains Mono"/>
               </a:rPr>
-              <a:t># or via Yak in Rhino:</a:t>
+              <a:t># Search for:</a:t>
             </a:r>
             <a:endParaRPr sz="720">
               <a:solidFill>
@@ -21589,7 +21591,7 @@
                 <a:cs typeface="JetBrains Mono"/>
                 <a:sym typeface="JetBrains Mono"/>
               </a:rPr>
-              <a:t>_PackageManager</a:t>
+              <a:t>Rhino-MCP-Platform</a:t>
             </a:r>
             <a:endParaRPr sz="720">
               <a:solidFill>
@@ -21650,7 +21652,7 @@
                 <a:cs typeface="Inter"/>
                 <a:sym typeface="Inter"/>
               </a:rPr>
-              <a:t>Downloads RhinoAI tool bindings &amp; JSON-RPC server.</a:t>
+              <a:t>Restart Rhino after the package installs.</a:t>
             </a:r>
             <a:endParaRPr sz="720">
               <a:solidFill>
@@ -21880,7 +21882,7 @@
               <a:buNone/>
             </a:pPr>
             <a:r>
-              <a:rPr b="0" i="0" lang="en-GB" sz="800" u="none" strike="noStrike">
+              <a:rPr lang="en-GB" sz="800">
                 <a:solidFill>
                   <a:srgbClr val="5A626A"/>
                 </a:solidFill>
@@ -21889,7 +21891,7 @@
                 <a:cs typeface="Inter"/>
                 <a:sym typeface="Inter"/>
               </a:rPr>
-              <a:t>Connect Claude Desktop or Cursor via JSON configuration.</a:t>
+              <a:t>In MCPConnect, click Install next to Codex.</a:t>
             </a:r>
             <a:endParaRPr b="1" i="0" sz="750" u="none" strike="noStrike">
               <a:solidFill>
@@ -22034,7 +22036,7 @@
               <a:buNone/>
             </a:pPr>
             <a:r>
-              <a:rPr b="1" i="0" lang="en-GB" sz="720" u="none" strike="noStrike">
+              <a:rPr b="1" lang="en-GB" sz="720">
                 <a:solidFill>
                   <a:srgbClr val="9CA3AF"/>
                 </a:solidFill>
@@ -22043,7 +22045,7 @@
                 <a:cs typeface="JetBrains Mono"/>
                 <a:sym typeface="JetBrains Mono"/>
               </a:rPr>
-              <a:t>claude_desktop_config.json</a:t>
+              <a:t>CODEX CONNECTION</a:t>
             </a:r>
             <a:endParaRPr b="1" i="0" sz="720" u="none" strike="noStrike">
               <a:solidFill>
@@ -22090,181 +22092,6 @@
                 <a:spcPts val="0"/>
               </a:spcBef>
               <a:spcAft>
-                <a:spcPts val="0"/>
-              </a:spcAft>
-              <a:buNone/>
-            </a:pPr>
-            <a:r>
-              <a:rPr lang="en-GB" sz="720">
-                <a:solidFill>
-                  <a:srgbClr val="38BDF8"/>
-                </a:solidFill>
-                <a:latin typeface="JetBrains Mono"/>
-                <a:ea typeface="JetBrains Mono"/>
-                <a:cs typeface="JetBrains Mono"/>
-                <a:sym typeface="JetBrains Mono"/>
-              </a:rPr>
-              <a:t>"mcpServers": {</a:t>
-            </a:r>
-            <a:endParaRPr sz="720">
-              <a:solidFill>
-                <a:srgbClr val="38BDF8"/>
-              </a:solidFill>
-              <a:latin typeface="JetBrains Mono"/>
-              <a:ea typeface="JetBrains Mono"/>
-              <a:cs typeface="JetBrains Mono"/>
-              <a:sym typeface="JetBrains Mono"/>
-            </a:endParaRPr>
-          </a:p>
-          <a:p>
-            <a:pPr indent="0" lvl="0" marL="0" rtl="0" algn="l">
-              <a:lnSpc>
-                <a:spcPct val="110000"/>
-              </a:lnSpc>
-              <a:spcBef>
-                <a:spcPts val="200"/>
-              </a:spcBef>
-              <a:spcAft>
-                <a:spcPts val="0"/>
-              </a:spcAft>
-              <a:buNone/>
-            </a:pPr>
-            <a:r>
-              <a:rPr lang="en-GB" sz="720">
-                <a:solidFill>
-                  <a:srgbClr val="38BDF8"/>
-                </a:solidFill>
-                <a:latin typeface="JetBrains Mono"/>
-                <a:ea typeface="JetBrains Mono"/>
-                <a:cs typeface="JetBrains Mono"/>
-                <a:sym typeface="JetBrains Mono"/>
-              </a:rPr>
-              <a:t>  "rhino": {</a:t>
-            </a:r>
-            <a:endParaRPr sz="720">
-              <a:solidFill>
-                <a:srgbClr val="38BDF8"/>
-              </a:solidFill>
-              <a:latin typeface="JetBrains Mono"/>
-              <a:ea typeface="JetBrains Mono"/>
-              <a:cs typeface="JetBrains Mono"/>
-              <a:sym typeface="JetBrains Mono"/>
-            </a:endParaRPr>
-          </a:p>
-          <a:p>
-            <a:pPr indent="0" lvl="0" marL="0" rtl="0" algn="l">
-              <a:lnSpc>
-                <a:spcPct val="110000"/>
-              </a:lnSpc>
-              <a:spcBef>
-                <a:spcPts val="200"/>
-              </a:spcBef>
-              <a:spcAft>
-                <a:spcPts val="0"/>
-              </a:spcAft>
-              <a:buNone/>
-            </a:pPr>
-            <a:r>
-              <a:rPr lang="en-GB" sz="720">
-                <a:solidFill>
-                  <a:srgbClr val="38BDF8"/>
-                </a:solidFill>
-                <a:latin typeface="JetBrains Mono"/>
-                <a:ea typeface="JetBrains Mono"/>
-                <a:cs typeface="JetBrains Mono"/>
-                <a:sym typeface="JetBrains Mono"/>
-              </a:rPr>
-              <a:t>    "command": "python",</a:t>
-            </a:r>
-            <a:endParaRPr sz="720">
-              <a:solidFill>
-                <a:srgbClr val="38BDF8"/>
-              </a:solidFill>
-              <a:latin typeface="JetBrains Mono"/>
-              <a:ea typeface="JetBrains Mono"/>
-              <a:cs typeface="JetBrains Mono"/>
-              <a:sym typeface="JetBrains Mono"/>
-            </a:endParaRPr>
-          </a:p>
-          <a:p>
-            <a:pPr indent="0" lvl="0" marL="0" rtl="0" algn="l">
-              <a:lnSpc>
-                <a:spcPct val="110000"/>
-              </a:lnSpc>
-              <a:spcBef>
-                <a:spcPts val="200"/>
-              </a:spcBef>
-              <a:spcAft>
-                <a:spcPts val="0"/>
-              </a:spcAft>
-              <a:buNone/>
-            </a:pPr>
-            <a:r>
-              <a:rPr lang="en-GB" sz="720">
-                <a:solidFill>
-                  <a:srgbClr val="38BDF8"/>
-                </a:solidFill>
-                <a:latin typeface="JetBrains Mono"/>
-                <a:ea typeface="JetBrains Mono"/>
-                <a:cs typeface="JetBrains Mono"/>
-                <a:sym typeface="JetBrains Mono"/>
-              </a:rPr>
-              <a:t>    "args": ["-m", "rhino_mcp"]</a:t>
-            </a:r>
-            <a:endParaRPr sz="720">
-              <a:solidFill>
-                <a:srgbClr val="38BDF8"/>
-              </a:solidFill>
-              <a:latin typeface="JetBrains Mono"/>
-              <a:ea typeface="JetBrains Mono"/>
-              <a:cs typeface="JetBrains Mono"/>
-              <a:sym typeface="JetBrains Mono"/>
-            </a:endParaRPr>
-          </a:p>
-          <a:p>
-            <a:pPr indent="0" lvl="0" marL="0" rtl="0" algn="l">
-              <a:lnSpc>
-                <a:spcPct val="110000"/>
-              </a:lnSpc>
-              <a:spcBef>
-                <a:spcPts val="200"/>
-              </a:spcBef>
-              <a:spcAft>
-                <a:spcPts val="0"/>
-              </a:spcAft>
-              <a:buNone/>
-            </a:pPr>
-            <a:r>
-              <a:rPr lang="en-GB" sz="720">
-                <a:solidFill>
-                  <a:srgbClr val="38BDF8"/>
-                </a:solidFill>
-                <a:latin typeface="JetBrains Mono"/>
-                <a:ea typeface="JetBrains Mono"/>
-                <a:cs typeface="JetBrains Mono"/>
-                <a:sym typeface="JetBrains Mono"/>
-              </a:rPr>
-              <a:t>  }</a:t>
-            </a:r>
-            <a:endParaRPr sz="720">
-              <a:solidFill>
-                <a:srgbClr val="38BDF8"/>
-              </a:solidFill>
-              <a:latin typeface="JetBrains Mono"/>
-              <a:ea typeface="JetBrains Mono"/>
-              <a:cs typeface="JetBrains Mono"/>
-              <a:sym typeface="JetBrains Mono"/>
-            </a:endParaRPr>
-          </a:p>
-          <a:p>
-            <a:pPr indent="0" lvl="0" marL="0" rtl="0" algn="l">
-              <a:lnSpc>
-                <a:spcPct val="110000"/>
-              </a:lnSpc>
-              <a:spcBef>
-                <a:spcPts val="200"/>
-              </a:spcBef>
-              <a:spcAft>
                 <a:spcPts val="200"/>
               </a:spcAft>
               <a:buNone/>
@@ -22279,7 +22106,7 @@
                 <a:cs typeface="JetBrains Mono"/>
                 <a:sym typeface="JetBrains Mono"/>
               </a:rPr>
-              <a:t>}</a:t>
+              <a:t>MCPConnect</a:t>
             </a:r>
             <a:endParaRPr sz="720">
               <a:solidFill>
@@ -22340,7 +22167,7 @@
                 <a:cs typeface="Inter"/>
                 <a:sym typeface="Inter"/>
               </a:rPr>
-              <a:t>Registers Rhino tools in Claude context window.</a:t>
+              <a:t>Restart Codex to load the Rhino tools.</a:t>
             </a:r>
             <a:endParaRPr sz="720">
               <a:solidFill>
@@ -22782,6 +22609,11 @@
               <a:spcAft>
                 <a:spcPts val="0"/>
               </a:spcAft>
+              <a:buClr>
+                <a:schemeClr val="dk1"/>
+              </a:buClr>
+              <a:buSzPts val="1100"/>
+              <a:buFont typeface="Arial"/>
               <a:buNone/>
             </a:pPr>
             <a:r>
@@ -22817,19 +22649,64 @@
               <a:spcAft>
                 <a:spcPts val="0"/>
               </a:spcAft>
+              <a:buClr>
+                <a:schemeClr val="dk1"/>
+              </a:buClr>
+              <a:buSzPts val="1100"/>
+              <a:buFont typeface="Arial"/>
               <a:buNone/>
             </a:pPr>
             <a:r>
               <a:rPr lang="en-GB" sz="720">
                 <a:solidFill>
-                  <a:srgbClr val="38BDF8"/>
+                  <a:srgbClr val="6B7280"/>
                 </a:solidFill>
                 <a:latin typeface="JetBrains Mono"/>
                 <a:ea typeface="JetBrains Mono"/>
                 <a:cs typeface="JetBrains Mono"/>
                 <a:sym typeface="JetBrains Mono"/>
               </a:rPr>
-              <a:t>RhinoMCPStart</a:t>
+              <a:t>MCPStart</a:t>
+            </a:r>
+            <a:endParaRPr sz="720">
+              <a:solidFill>
+                <a:srgbClr val="6B7280"/>
+              </a:solidFill>
+              <a:latin typeface="JetBrains Mono"/>
+              <a:ea typeface="JetBrains Mono"/>
+              <a:cs typeface="JetBrains Mono"/>
+              <a:sym typeface="JetBrains Mono"/>
+            </a:endParaRPr>
+          </a:p>
+          <a:p>
+            <a:pPr indent="0" lvl="0" marL="0" rtl="0" algn="l">
+              <a:lnSpc>
+                <a:spcPct val="110000"/>
+              </a:lnSpc>
+              <a:spcBef>
+                <a:spcPts val="200"/>
+              </a:spcBef>
+              <a:spcAft>
+                <a:spcPts val="0"/>
+              </a:spcAft>
+              <a:buClr>
+                <a:schemeClr val="dk1"/>
+              </a:buClr>
+              <a:buSzPts val="1100"/>
+              <a:buFont typeface="Arial"/>
+              <a:buNone/>
+            </a:pPr>
+            <a:r>
+              <a:rPr lang="en-GB" sz="720">
+                <a:solidFill>
+                  <a:srgbClr val="6B7280"/>
+                </a:solidFill>
+                <a:latin typeface="JetBrains Mono"/>
+                <a:ea typeface="JetBrains Mono"/>
+                <a:cs typeface="JetBrains Mono"/>
+                <a:sym typeface="JetBrains Mono"/>
+              </a:rPr>
+              <a:t># Prompt: 'Draw a torus'</a:t>
             </a:r>
             <a:endParaRPr sz="720">
               <a:solidFill>
@@ -22855,16 +22732,7 @@
               <a:buNone/>
             </a:pPr>
             <a:r>
-              <a:rPr lang="en-GB" sz="720">
-                <a:solidFill>
-                  <a:srgbClr val="6B7280"/>
-                </a:solidFill>
-                <a:latin typeface="JetBrains Mono"/>
-                <a:ea typeface="JetBrains Mono"/>
-                <a:cs typeface="JetBrains Mono"/>
-                <a:sym typeface="JetBrains Mono"/>
-              </a:rPr>
-              <a:t># In Claude: 'Draw a torus'</a:t>
+              <a:t/>
             </a:r>
             <a:endParaRPr sz="720">
               <a:solidFill>
@@ -22925,7 +22793,7 @@
                 <a:cs typeface="Inter"/>
                 <a:sym typeface="Inter"/>
               </a:rPr>
-              <a:t>Status: Active handshake &amp; real-time canvas feedback.</a:t>
+              <a:t>Check: read the model, then create one torus.</a:t>
             </a:r>
             <a:endParaRPr sz="720">
               <a:solidFill>
@@ -27196,7 +27064,7 @@
                 <a:buNone/>
               </a:pPr>
               <a:r>
-                <a:rPr b="0" i="0" lang="en-GB" sz="2100" u="none" strike="noStrike">
+                <a:rPr lang="en-GB" sz="2100">
                   <a:solidFill>
                     <a:srgbClr val="111315"/>
                   </a:solidFill>
@@ -27205,7 +27073,7 @@
                   <a:cs typeface="Space Grotesk"/>
                   <a:sym typeface="Space Grotesk"/>
                 </a:rPr>
-                <a:t>System Example 2B: Grasshopper Custom Analysis Scripts</a:t>
+                <a:t>System Example 2B: Airflow in a 2D Slice</a:t>
               </a:r>
               <a:endParaRPr b="0" i="0" sz="2100" u="none" strike="noStrike">
                 <a:solidFill>
@@ -27254,7 +27122,7 @@
                 <a:buNone/>
               </a:pPr>
               <a:r>
-                <a:rPr b="0" i="0" lang="en-GB" sz="1125" u="none" strike="noStrike">
+                <a:rPr lang="en-GB" sz="1125">
                   <a:solidFill>
                     <a:srgbClr val="5A626A"/>
                   </a:solidFill>
@@ -27263,7 +27131,7 @@
                   <a:cs typeface="Space Grotesk SemiBold"/>
                   <a:sym typeface="Space Grotesk SemiBold"/>
                 </a:rPr>
-                <a:t>Grasshopper scripting can implement specific numerical procedures and simulation scripts, including airflow approximations.</a:t>
+                <a:t>A small lattice Boltzmann solver shows flow around building footprints in a horizontal slice.</a:t>
               </a:r>
               <a:endParaRPr b="0" i="0" sz="1125" u="none" strike="noStrike">
                 <a:solidFill>
@@ -27442,7 +27310,7 @@
                 <a:buNone/>
               </a:pPr>
               <a:r>
-                <a:rPr b="1" i="0" lang="en-GB" sz="1050" u="none" strike="noStrike">
+                <a:rPr b="1" lang="en-GB" sz="1050">
                   <a:solidFill>
                     <a:srgbClr val="111315"/>
                   </a:solidFill>
@@ -27451,7 +27319,7 @@
                   <a:cs typeface="Inter"/>
                   <a:sym typeface="Inter"/>
                 </a:rPr>
-                <a:t>Engineering Problem Query</a:t>
+                <a:t>Building Slice</a:t>
               </a:r>
               <a:endParaRPr b="1" i="0" sz="750" u="none" strike="noStrike">
                 <a:solidFill>
@@ -27477,7 +27345,7 @@
                 <a:buNone/>
               </a:pPr>
               <a:r>
-                <a:rPr b="0" i="0" lang="en-GB" sz="975" u="none" strike="noStrike">
+                <a:rPr lang="en-GB" sz="975">
                   <a:solidFill>
                     <a:srgbClr val="5A626A"/>
                   </a:solidFill>
@@ -27486,7 +27354,7 @@
                   <a:cs typeface="Inter"/>
                   <a:sym typeface="Inter"/>
                 </a:rPr>
-                <a:t>Querying mathematical formulations rather than standard software packages.</a:t>
+                <a:t>Closed footprints, inlet speed, grid size and viscosity.</a:t>
               </a:r>
               <a:endParaRPr b="1" i="0" sz="750" u="none" strike="noStrike">
                 <a:solidFill>
@@ -27512,7 +27380,7 @@
                 <a:buNone/>
               </a:pPr>
               <a:r>
-                <a:rPr b="0" i="1" lang="en-GB" sz="975" u="none" strike="noStrike">
+                <a:rPr i="1" lang="en-GB" sz="975">
                   <a:solidFill>
                     <a:srgbClr val="111315"/>
                   </a:solidFill>
@@ -27524,7 +27392,7 @@
                   <a:cs typeface="Inter"/>
                   <a:sym typeface="Inter"/>
                 </a:rPr>
-                <a:t>Formulation query for airflow vector fields.</a:t>
+                <a:t>Compare two layouts with the same flow settings.</a:t>
               </a:r>
               <a:endParaRPr b="1" i="0" sz="750" u="none" strike="noStrike">
                 <a:solidFill>
@@ -27803,7 +27671,7 @@
                 <a:buNone/>
               </a:pPr>
               <a:r>
-                <a:rPr b="1" i="0" lang="en-GB" sz="1050" u="none" strike="noStrike">
+                <a:rPr b="1" lang="en-GB" sz="1050">
                   <a:solidFill>
                     <a:srgbClr val="111315"/>
                   </a:solidFill>
@@ -27812,7 +27680,7 @@
                   <a:cs typeface="Inter"/>
                   <a:sym typeface="Inter"/>
                 </a:rPr>
-                <a:t>Model Response</a:t>
+                <a:t>Adapt Existing Code</a:t>
               </a:r>
               <a:endParaRPr b="1" i="0" sz="750" u="none" strike="noStrike">
                 <a:solidFill>
@@ -27847,7 +27715,19 @@
                   <a:cs typeface="Inter"/>
                   <a:sym typeface="Inter"/>
                 </a:rPr>
-                <a:t>• Outlines vector formulas</a:t>
+                <a:t>• </a:t>
+              </a:r>
+              <a:r>
+                <a:rPr lang="en-GB" sz="975">
+                  <a:solidFill>
+                    <a:srgbClr val="111315"/>
+                  </a:solidFill>
+                  <a:latin typeface="Inter"/>
+                  <a:ea typeface="Inter"/>
+                  <a:cs typeface="Inter"/>
+                  <a:sym typeface="Inter"/>
+                </a:rPr>
+                <a:t>Ports D2Q9 / TRT from GitHub</a:t>
               </a:r>
               <a:endParaRPr b="1" i="0" sz="750" u="none" strike="noStrike">
                 <a:solidFill>
@@ -27882,7 +27762,19 @@
                   <a:cs typeface="Inter"/>
                   <a:sym typeface="Inter"/>
                 </a:rPr>
-                <a:t>• Generates custom Grasshopper C# or Python script</a:t>
+                <a:t>• </a:t>
+              </a:r>
+              <a:r>
+                <a:rPr lang="en-GB" sz="975">
+                  <a:solidFill>
+                    <a:srgbClr val="111315"/>
+                  </a:solidFill>
+                  <a:latin typeface="Inter"/>
+                  <a:ea typeface="Inter"/>
+                  <a:cs typeface="Inter"/>
+                  <a:sym typeface="Inter"/>
+                </a:rPr>
+                <a:t>Runs a small Python solver</a:t>
               </a:r>
               <a:endParaRPr b="1" i="0" sz="750" u="none" strike="noStrike">
                 <a:solidFill>
@@ -27908,7 +27800,7 @@
                 <a:buNone/>
               </a:pPr>
               <a:r>
-                <a:rPr b="0" i="0" lang="en-GB" sz="825" u="none" strike="noStrike">
+                <a:rPr lang="en-GB" sz="825">
                   <a:solidFill>
                     <a:srgbClr val="D9381E"/>
                   </a:solidFill>
@@ -27917,7 +27809,7 @@
                   <a:cs typeface="JetBrains Mono"/>
                   <a:sym typeface="JetBrains Mono"/>
                 </a:rPr>
-                <a:t>// Vector Field Calculation</a:t>
+                <a:t>// LBM time step</a:t>
               </a:r>
               <a:endParaRPr b="1" i="0" sz="750" u="none" strike="noStrike">
                 <a:solidFill>
@@ -27943,7 +27835,7 @@
                 <a:buNone/>
               </a:pPr>
               <a:r>
-                <a:rPr b="0" i="0" lang="en-GB" sz="825" u="none" strike="noStrike">
+                <a:rPr lang="en-GB" sz="825">
                   <a:solidFill>
                     <a:srgbClr val="F8F9FA"/>
                   </a:solidFill>
@@ -27955,7 +27847,7 @@
                   <a:cs typeface="JetBrains Mono"/>
                   <a:sym typeface="JetBrains Mono"/>
                 </a:rPr>
-                <a:t>Vector3D flow = Vector3D.Zero;</a:t>
+                <a:t>for each step {</a:t>
               </a:r>
               <a:endParaRPr b="1" i="0" sz="750" u="none" strike="noStrike">
                 <a:solidFill>
@@ -27981,7 +27873,7 @@
                 <a:buNone/>
               </a:pPr>
               <a:r>
-                <a:rPr b="0" i="0" lang="en-GB" sz="825" u="none" strike="noStrike">
+                <a:rPr lang="en-GB" sz="825">
                   <a:solidFill>
                     <a:srgbClr val="F8F9FA"/>
                   </a:solidFill>
@@ -27993,7 +27885,7 @@
                   <a:cs typeface="JetBrains Mono"/>
                   <a:sym typeface="JetBrains Mono"/>
                 </a:rPr>
-                <a:t>foreach(var obstacle in site) {</a:t>
+                <a:t>collide_and_stream()</a:t>
               </a:r>
               <a:endParaRPr b="1" i="0" sz="750" u="none" strike="noStrike">
                 <a:solidFill>
@@ -28019,7 +27911,7 @@
                 <a:buNone/>
               </a:pPr>
               <a:r>
-                <a:rPr b="0" i="0" lang="en-GB" sz="825" u="none" strike="noStrike">
+                <a:rPr lang="en-GB" sz="825">
                   <a:solidFill>
                     <a:srgbClr val="F8F9FA"/>
                   </a:solidFill>
@@ -28031,7 +27923,7 @@
                   <a:cs typeface="JetBrains Mono"/>
                   <a:sym typeface="JetBrains Mono"/>
                 </a:rPr>
-                <a:t>flow += ComputeDeflection(...);</a:t>
+                <a:t>apply_boundaries()</a:t>
               </a:r>
               <a:endParaRPr b="1" i="0" sz="750" u="none" strike="noStrike">
                 <a:solidFill>
@@ -28348,7 +28240,7 @@
                 <a:buNone/>
               </a:pPr>
               <a:r>
-                <a:rPr b="1" i="0" lang="en-GB" sz="1050" u="none" strike="noStrike">
+                <a:rPr b="1" lang="en-GB" sz="1050">
                   <a:solidFill>
                     <a:srgbClr val="111315"/>
                   </a:solidFill>
@@ -28357,7 +28249,7 @@
                   <a:cs typeface="Inter"/>
                   <a:sym typeface="Inter"/>
                 </a:rPr>
-                <a:t>Custom Airflow Calculation Script</a:t>
+                <a:t>2D Flow Field</a:t>
               </a:r>
               <a:endParaRPr b="1" i="0" sz="750" u="none" strike="noStrike">
                 <a:solidFill>
@@ -28383,7 +28275,7 @@
                 <a:buNone/>
               </a:pPr>
               <a:r>
-                <a:rPr b="0" i="0" lang="en-GB" sz="975" u="none" strike="noStrike">
+                <a:rPr lang="en-GB" sz="975">
                   <a:solidFill>
                     <a:srgbClr val="5A626A"/>
                   </a:solidFill>
@@ -28392,7 +28284,7 @@
                   <a:cs typeface="Inter"/>
                   <a:sym typeface="Inter"/>
                 </a:rPr>
-                <a:t>A numeric calculation script running directly within Grasshopper.</a:t>
+                <a:t>Teaching model. Check stability before comparing layouts.</a:t>
               </a:r>
               <a:endParaRPr b="1" i="0" sz="750" u="none" strike="noStrike">
                 <a:solidFill>
@@ -28468,7 +28360,22 @@
                   <a:cs typeface="JetBrains Mono"/>
                   <a:sym typeface="JetBrains Mono"/>
                 </a:rPr>
-                <a:t>• Vector Grid Values</a:t>
+                <a:t>• </a:t>
+              </a:r>
+              <a:r>
+                <a:rPr lang="en-GB" sz="750">
+                  <a:solidFill>
+                    <a:srgbClr val="5A626A"/>
+                  </a:solidFill>
+                  <a:highlight>
+                    <a:srgbClr val="F8F9FA"/>
+                  </a:highlight>
+                  <a:latin typeface="JetBrains Mono"/>
+                  <a:ea typeface="JetBrains Mono"/>
+                  <a:cs typeface="JetBrains Mono"/>
+                  <a:sym typeface="JetBrains Mono"/>
+                </a:rPr>
+                <a:t>Relative speed</a:t>
               </a:r>
               <a:endParaRPr b="1" i="0" sz="750" u="none" strike="noStrike">
                 <a:solidFill>
@@ -28506,7 +28413,22 @@
                   <a:cs typeface="JetBrains Mono"/>
                   <a:sym typeface="JetBrains Mono"/>
                 </a:rPr>
-                <a:t>• Velocity Streamlines</a:t>
+                <a:t>• </a:t>
+              </a:r>
+              <a:r>
+                <a:rPr lang="en-GB" sz="750">
+                  <a:solidFill>
+                    <a:srgbClr val="5A626A"/>
+                  </a:solidFill>
+                  <a:highlight>
+                    <a:srgbClr val="F8F9FA"/>
+                  </a:highlight>
+                  <a:latin typeface="JetBrains Mono"/>
+                  <a:ea typeface="JetBrains Mono"/>
+                  <a:cs typeface="JetBrains Mono"/>
+                  <a:sym typeface="JetBrains Mono"/>
+                </a:rPr>
+                <a:t>Velocity vectors</a:t>
               </a:r>
               <a:endParaRPr b="1" i="0" sz="750" u="none" strike="noStrike">
                 <a:solidFill>
@@ -28544,7 +28466,22 @@
                   <a:cs typeface="JetBrains Mono"/>
                   <a:sym typeface="JetBrains Mono"/>
                 </a:rPr>
-                <a:t>• Airflow Velocity Distribution</a:t>
+                <a:t>• </a:t>
+              </a:r>
+              <a:r>
+                <a:rPr lang="en-GB" sz="750">
+                  <a:solidFill>
+                    <a:srgbClr val="5A626A"/>
+                  </a:solidFill>
+                  <a:highlight>
+                    <a:srgbClr val="F8F9FA"/>
+                  </a:highlight>
+                  <a:latin typeface="JetBrains Mono"/>
+                  <a:ea typeface="JetBrains Mono"/>
+                  <a:cs typeface="JetBrains Mono"/>
+                  <a:sym typeface="JetBrains Mono"/>
+                </a:rPr>
+                <a:t>Wake pattern</a:t>
               </a:r>
               <a:endParaRPr b="1" i="0" sz="750" u="none" strike="noStrike">
                 <a:solidFill>
@@ -55272,6 +55209,285 @@
 </file>
 
 <file path=ppt/theme/theme1.xml><?xml version="1.0" encoding="utf-8"?>
+<a:theme xmlns:a="http://schemas.openxmlformats.org/drawingml/2006/main" xmlns:r="http://schemas.openxmlformats.org/officeDocument/2006/relationships" name="Simple Light">
+  <a:themeElements>
+    <a:clrScheme name="Simple Light">
+      <a:dk1>
+        <a:srgbClr val="000000"/>
+      </a:dk1>
+      <a:lt1>
+        <a:srgbClr val="FFFFFF"/>
+      </a:lt1>
+      <a:dk2>
+        <a:srgbClr val="595959"/>
+      </a:dk2>
+      <a:lt2>
+        <a:srgbClr val="EEEEEE"/>
+      </a:lt2>
+      <a:accent1>
+        <a:srgbClr val="4285F4"/>
+      </a:accent1>
+      <a:accent2>
+        <a:srgbClr val="212121"/>
+      </a:accent2>
+      <a:accent3>
+        <a:srgbClr val="78909C"/>
+      </a:accent3>
+      <a:accent4>
+        <a:srgbClr val="FFAB40"/>
+      </a:accent4>
+      <a:accent5>
+        <a:srgbClr val="0097A7"/>
+      </a:accent5>
+      <a:accent6>
+        <a:srgbClr val="EEFF41"/>
+      </a:accent6>
+      <a:hlink>
+        <a:srgbClr val="0097A7"/>
+      </a:hlink>
+      <a:folHlink>
+        <a:srgbClr val="0097A7"/>
+      </a:folHlink>
+    </a:clrScheme>
+    <a:fontScheme name="Office">
+      <a:majorFont>
+        <a:latin typeface="Arial"/>
+        <a:ea typeface=""/>
+        <a:cs typeface=""/>
+        <a:font script="Jpan" typeface="ＭＳ Ｐゴシック"/>
+        <a:font script="Hang" typeface="맑은 고딕"/>
+        <a:font script="Hans" typeface="宋体"/>
+        <a:font script="Hant" typeface="新細明體"/>
+        <a:font script="Arab" typeface="Times New Roman"/>
+        <a:font script="Hebr" typeface="Times New Roman"/>
+        <a:font script="Thai" typeface="Angsana New"/>
+        <a:font script="Ethi" typeface="Nyala"/>
+        <a:font script="Beng" typeface="Vrinda"/>
+        <a:font script="Gujr" typeface="Shruti"/>
+        <a:font script="Khmr" typeface="MoolBoran"/>
+        <a:font script="Knda" typeface="Tunga"/>
+        <a:font script="Guru" typeface="Raavi"/>
+        <a:font script="Cans" typeface="Euphemia"/>
+        <a:font script="Cher" typeface="Plantagenet Cherokee"/>
+        <a:font script="Yiii" typeface="Microsoft Yi Baiti"/>
+        <a:font script="Tibt" typeface="Microsoft Himalaya"/>
+        <a:font script="Thaa" typeface="MV Boli"/>
+        <a:font script="Deva" typeface="Mangal"/>
+        <a:font script="Telu" typeface="Gautami"/>
+        <a:font script="Taml" typeface="Latha"/>
+        <a:font script="Syrc" typeface="Estrangelo Edessa"/>
+        <a:font script="Orya" typeface="Kalinga"/>
+        <a:font script="Mlym" typeface="Kartika"/>
+        <a:font script="Laoo" typeface="DokChampa"/>
+        <a:font script="Sinh" typeface="Iskoola Pota"/>
+        <a:font script="Mong" typeface="Mongolian Baiti"/>
+        <a:font script="Viet" typeface="Times New Roman"/>
+        <a:font script="Uigh" typeface="Microsoft Uighur"/>
+        <a:font script="Geor" typeface="Sylfaen"/>
+      </a:majorFont>
+      <a:minorFont>
+        <a:latin typeface="Arial"/>
+        <a:ea typeface=""/>
+        <a:cs typeface=""/>
+        <a:font script="Jpan" typeface="ＭＳ Ｐゴシック"/>
+        <a:font script="Hang" typeface="맑은 고딕"/>
+        <a:font script="Hans" typeface="宋体"/>
+        <a:font script="Hant" typeface="新細明體"/>
+        <a:font script="Arab" typeface="Arial"/>
+        <a:font script="Hebr" typeface="Arial"/>
+        <a:font script="Thai" typeface="Cordia New"/>
+        <a:font script="Ethi" typeface="Nyala"/>
+        <a:font script="Beng" typeface="Vrinda"/>
+        <a:font script="Gujr" typeface="Shruti"/>
+        <a:font script="Khmr" typeface="DaunPenh"/>
+        <a:font script="Knda" typeface="Tunga"/>
+        <a:font script="Guru" typeface="Raavi"/>
+        <a:font script="Cans" typeface="Euphemia"/>
+        <a:font script="Cher" typeface="Plantagenet Cherokee"/>
+        <a:font script="Yiii" typeface="Microsoft Yi Baiti"/>
+        <a:font script="Tibt" typeface="Microsoft Himalaya"/>
+        <a:font script="Thaa" typeface="MV Boli"/>
+        <a:font script="Deva" typeface="Mangal"/>
+        <a:font script="Telu" typeface="Gautami"/>
+        <a:font script="Taml" typeface="Latha"/>
+        <a:font script="Syrc" typeface="Estrangelo Edessa"/>
+        <a:font script="Orya" typeface="Kalinga"/>
+        <a:font script="Mlym" typeface="Kartika"/>
+        <a:font script="Laoo" typeface="DokChampa"/>
+        <a:font script="Sinh" typeface="Iskoola Pota"/>
+        <a:font script="Mong" typeface="Mongolian Baiti"/>
+        <a:font script="Viet" typeface="Arial"/>
+        <a:font script="Uigh" typeface="Microsoft Uighur"/>
+        <a:font script="Geor" typeface="Sylfaen"/>
+      </a:minorFont>
+    </a:fontScheme>
+    <a:fmtScheme name="Office">
+      <a:fillStyleLst>
+        <a:solidFill>
+          <a:schemeClr val="phClr"/>
+        </a:solidFill>
+        <a:gradFill rotWithShape="1">
+          <a:gsLst>
+            <a:gs pos="0">
+              <a:schemeClr val="phClr">
+                <a:tint val="50000"/>
+                <a:satMod val="300000"/>
+              </a:schemeClr>
+            </a:gs>
+            <a:gs pos="35000">
+              <a:schemeClr val="phClr">
+                <a:tint val="37000"/>
+                <a:satMod val="300000"/>
+              </a:schemeClr>
+            </a:gs>
+            <a:gs pos="100000">
+              <a:schemeClr val="phClr">
+                <a:tint val="15000"/>
+                <a:satMod val="350000"/>
+              </a:schemeClr>
+            </a:gs>
+          </a:gsLst>
+          <a:lin ang="16200000" scaled="1"/>
+        </a:gradFill>
+        <a:gradFill rotWithShape="1">
+          <a:gsLst>
+            <a:gs pos="0">
+              <a:schemeClr val="phClr">
+                <a:tint val="100000"/>
+                <a:shade val="100000"/>
+                <a:satMod val="130000"/>
+              </a:schemeClr>
+            </a:gs>
+            <a:gs pos="100000">
+              <a:schemeClr val="phClr">
+                <a:tint val="50000"/>
+                <a:shade val="100000"/>
+                <a:satMod val="350000"/>
+              </a:schemeClr>
+            </a:gs>
+          </a:gsLst>
+          <a:lin ang="16200000" scaled="0"/>
+        </a:gradFill>
+      </a:fillStyleLst>
+      <a:lnStyleLst>
+        <a:ln w="9525" cap="flat" cmpd="sng" algn="ctr">
+          <a:solidFill>
+            <a:schemeClr val="phClr">
+              <a:shade val="95000"/>
+              <a:satMod val="105000"/>
+            </a:schemeClr>
+          </a:solidFill>
+          <a:prstDash val="solid"/>
+        </a:ln>
+        <a:ln w="25400" cap="flat" cmpd="sng" algn="ctr">
+          <a:solidFill>
+            <a:schemeClr val="phClr"/>
+          </a:solidFill>
+          <a:prstDash val="solid"/>
+        </a:ln>
+        <a:ln w="38100" cap="flat" cmpd="sng" algn="ctr">
+          <a:solidFill>
+            <a:schemeClr val="phClr"/>
+          </a:solidFill>
+          <a:prstDash val="solid"/>
+        </a:ln>
+      </a:lnStyleLst>
+      <a:effectStyleLst>
+        <a:effectStyle>
+          <a:effectLst>
+            <a:outerShdw blurRad="40000" dist="20000" dir="5400000" rotWithShape="0">
+              <a:srgbClr val="000000">
+                <a:alpha val="38000"/>
+              </a:srgbClr>
+            </a:outerShdw>
+          </a:effectLst>
+        </a:effectStyle>
+        <a:effectStyle>
+          <a:effectLst>
+            <a:outerShdw blurRad="40000" dist="23000" dir="5400000" rotWithShape="0">
+              <a:srgbClr val="000000">
+                <a:alpha val="35000"/>
+              </a:srgbClr>
+            </a:outerShdw>
+          </a:effectLst>
+        </a:effectStyle>
+        <a:effectStyle>
+          <a:effectLst>
+            <a:outerShdw blurRad="40000" dist="23000" dir="5400000" rotWithShape="0">
+              <a:srgbClr val="000000">
+                <a:alpha val="35000"/>
+              </a:srgbClr>
+            </a:outerShdw>
+          </a:effectLst>
+          <a:scene3d>
+            <a:camera prst="orthographicFront">
+              <a:rot lat="0" lon="0" rev="0"/>
+            </a:camera>
+            <a:lightRig rig="threePt" dir="t">
+              <a:rot lat="0" lon="0" rev="1200000"/>
+            </a:lightRig>
+          </a:scene3d>
+          <a:sp3d>
+            <a:bevelT w="63500" h="25400"/>
+          </a:sp3d>
+        </a:effectStyle>
+      </a:effectStyleLst>
+      <a:bgFillStyleLst>
+        <a:solidFill>
+          <a:schemeClr val="phClr"/>
+        </a:solidFill>
+        <a:gradFill rotWithShape="1">
+          <a:gsLst>
+            <a:gs pos="0">
+              <a:schemeClr val="phClr">
+                <a:tint val="40000"/>
+                <a:satMod val="350000"/>
+              </a:schemeClr>
+            </a:gs>
+            <a:gs pos="40000">
+              <a:schemeClr val="phClr">
+                <a:tint val="45000"/>
+                <a:shade val="99000"/>
+                <a:satMod val="350000"/>
+              </a:schemeClr>
+            </a:gs>
+            <a:gs pos="100000">
+              <a:schemeClr val="phClr">
+                <a:shade val="20000"/>
+                <a:satMod val="255000"/>
+              </a:schemeClr>
+            </a:gs>
+          </a:gsLst>
+          <a:path path="circle">
+            <a:fillToRect l="50000" t="-80000" r="50000" b="180000"/>
+          </a:path>
+        </a:gradFill>
+        <a:gradFill rotWithShape="1">
+          <a:gsLst>
+            <a:gs pos="0">
+              <a:schemeClr val="phClr">
+                <a:tint val="80000"/>
+                <a:satMod val="300000"/>
+              </a:schemeClr>
+            </a:gs>
+            <a:gs pos="100000">
+              <a:schemeClr val="phClr">
+                <a:shade val="30000"/>
+                <a:satMod val="200000"/>
+              </a:schemeClr>
+            </a:gs>
+          </a:gsLst>
+          <a:path path="circle">
+            <a:fillToRect l="50000" t="50000" r="50000" b="50000"/>
+          </a:path>
+        </a:gradFill>
+      </a:bgFillStyleLst>
+    </a:fmtScheme>
+  </a:themeElements>
+</a:theme>
+</file>
+
+<file path=ppt/theme/theme2.xml><?xml version="1.0" encoding="utf-8"?>
 <a:theme xmlns:a="http://schemas.openxmlformats.org/drawingml/2006/main" xmlns:r="http://schemas.openxmlformats.org/officeDocument/2006/relationships">
   <a:themeElements>
     <a:clrScheme name="Default">
@@ -55548,283 +55764,4 @@
     </a:fmtScheme>
   </a:themeElements>
 </a:theme>
-</file>
-
-<file path=ppt/theme/theme2.xml><?xml version="1.0" encoding="utf-8"?>
-<a:theme xmlns:a="http://schemas.openxmlformats.org/drawingml/2006/main" xmlns:r="http://schemas.openxmlformats.org/officeDocument/2006/relationships" name="Simple Light">
-  <a:themeElements>
-    <a:clrScheme name="Simple Light">
-      <a:dk1>
-        <a:srgbClr val="000000"/>
-      </a:dk1>
-      <a:lt1>
-        <a:srgbClr val="FFFFFF"/>
-      </a:lt1>
-      <a:dk2>
-        <a:srgbClr val="595959"/>
-      </a:dk2>
-      <a:lt2>
-        <a:srgbClr val="EEEEEE"/>
-      </a:lt2>
-      <a:accent1>
-        <a:srgbClr val="4285F4"/>
-      </a:accent1>
-      <a:accent2>
-        <a:srgbClr val="212121"/>
-      </a:accent2>
-      <a:accent3>
-        <a:srgbClr val="78909C"/>
-      </a:accent3>
-      <a:accent4>
-        <a:srgbClr val="FFAB40"/>
-      </a:accent4>
-      <a:accent5>
-        <a:srgbClr val="0097A7"/>
-      </a:accent5>
-      <a:accent6>
-        <a:srgbClr val="EEFF41"/>
-      </a:accent6>
-      <a:hlink>
-        <a:srgbClr val="0097A7"/>
-      </a:hlink>
-      <a:folHlink>
-        <a:srgbClr val="0097A7"/>
-      </a:folHlink>
-    </a:clrScheme>
-    <a:fontScheme name="Office">
-      <a:majorFont>
-        <a:latin typeface="Arial"/>
-        <a:ea typeface=""/>
-        <a:cs typeface=""/>
-        <a:font script="Jpan" typeface="ＭＳ Ｐゴシック"/>
-        <a:font script="Hang" typeface="맑은 고딕"/>
-        <a:font script="Hans" typeface="宋体"/>
-        <a:font script="Hant" typeface="新細明體"/>
-        <a:font script="Arab" typeface="Times New Roman"/>
-        <a:font script="Hebr" typeface="Times New Roman"/>
-        <a:font script="Thai" typeface="Angsana New"/>
-        <a:font script="Ethi" typeface="Nyala"/>
-        <a:font script="Beng" typeface="Vrinda"/>
-        <a:font script="Gujr" typeface="Shruti"/>
-        <a:font script="Khmr" typeface="MoolBoran"/>
-        <a:font script="Knda" typeface="Tunga"/>
-        <a:font script="Guru" typeface="Raavi"/>
-        <a:font script="Cans" typeface="Euphemia"/>
-        <a:font script="Cher" typeface="Plantagenet Cherokee"/>
-        <a:font script="Yiii" typeface="Microsoft Yi Baiti"/>
-        <a:font script="Tibt" typeface="Microsoft Himalaya"/>
-        <a:font script="Thaa" typeface="MV Boli"/>
-        <a:font script="Deva" typeface="Mangal"/>
-        <a:font script="Telu" typeface="Gautami"/>
-        <a:font script="Taml" typeface="Latha"/>
-        <a:font script="Syrc" typeface="Estrangelo Edessa"/>
-        <a:font script="Orya" typeface="Kalinga"/>
-        <a:font script="Mlym" typeface="Kartika"/>
-        <a:font script="Laoo" typeface="DokChampa"/>
-        <a:font script="Sinh" typeface="Iskoola Pota"/>
-        <a:font script="Mong" typeface="Mongolian Baiti"/>
-        <a:font script="Viet" typeface="Times New Roman"/>
-        <a:font script="Uigh" typeface="Microsoft Uighur"/>
-        <a:font script="Geor" typeface="Sylfaen"/>
-      </a:majorFont>
-      <a:minorFont>
-        <a:latin typeface="Arial"/>
-        <a:ea typeface=""/>
-        <a:cs typeface=""/>
-        <a:font script="Jpan" typeface="ＭＳ Ｐゴシック"/>
-        <a:font script="Hang" typeface="맑은 고딕"/>
-        <a:font script="Hans" typeface="宋体"/>
-        <a:font script="Hant" typeface="新細明體"/>
-        <a:font script="Arab" typeface="Arial"/>
-        <a:font script="Hebr" typeface="Arial"/>
-        <a:font script="Thai" typeface="Cordia New"/>
-        <a:font script="Ethi" typeface="Nyala"/>
-        <a:font script="Beng" typeface="Vrinda"/>
-        <a:font script="Gujr" typeface="Shruti"/>
-        <a:font script="Khmr" typeface="DaunPenh"/>
-        <a:font script="Knda" typeface="Tunga"/>
-        <a:font script="Guru" typeface="Raavi"/>
-        <a:font script="Cans" typeface="Euphemia"/>
-        <a:font script="Cher" typeface="Plantagenet Cherokee"/>
-        <a:font script="Yiii" typeface="Microsoft Yi Baiti"/>
-        <a:font script="Tibt" typeface="Microsoft Himalaya"/>
-        <a:font script="Thaa" typeface="MV Boli"/>
-        <a:font script="Deva" typeface="Mangal"/>
-        <a:font script="Telu" typeface="Gautami"/>
-        <a:font script="Taml" typeface="Latha"/>
-        <a:font script="Syrc" typeface="Estrangelo Edessa"/>
-        <a:font script="Orya" typeface="Kalinga"/>
-        <a:font script="Mlym" typeface="Kartika"/>
-        <a:font script="Laoo" typeface="DokChampa"/>
-        <a:font script="Sinh" typeface="Iskoola Pota"/>
-        <a:font script="Mong" typeface="Mongolian Baiti"/>
-        <a:font script="Viet" typeface="Arial"/>
-        <a:font script="Uigh" typeface="Microsoft Uighur"/>
-        <a:font script="Geor" typeface="Sylfaen"/>
-      </a:minorFont>
-    </a:fontScheme>
-    <a:fmtScheme name="Office">
-      <a:fillStyleLst>
-        <a:solidFill>
-          <a:schemeClr val="phClr"/>
-        </a:solidFill>
-        <a:gradFill rotWithShape="1">
-          <a:gsLst>
-            <a:gs pos="0">
-              <a:schemeClr val="phClr">
-                <a:tint val="50000"/>
-                <a:satMod val="300000"/>
-              </a:schemeClr>
-            </a:gs>
-            <a:gs pos="35000">
-              <a:schemeClr val="phClr">
-                <a:tint val="37000"/>
-                <a:satMod val="300000"/>
-              </a:schemeClr>
-            </a:gs>
-            <a:gs pos="100000">
-              <a:schemeClr val="phClr">
-                <a:tint val="15000"/>
-                <a:satMod val="350000"/>
-              </a:schemeClr>
-            </a:gs>
-          </a:gsLst>
-          <a:lin ang="16200000" scaled="1"/>
-        </a:gradFill>
-        <a:gradFill rotWithShape="1">
-          <a:gsLst>
-            <a:gs pos="0">
-              <a:schemeClr val="phClr">
-                <a:tint val="100000"/>
-                <a:shade val="100000"/>
-                <a:satMod val="130000"/>
-              </a:schemeClr>
-            </a:gs>
-            <a:gs pos="100000">
-              <a:schemeClr val="phClr">
-                <a:tint val="50000"/>
-                <a:shade val="100000"/>
-                <a:satMod val="350000"/>
-              </a:schemeClr>
-            </a:gs>
-          </a:gsLst>
-          <a:lin ang="16200000" scaled="0"/>
-        </a:gradFill>
-      </a:fillStyleLst>
-      <a:lnStyleLst>
-        <a:ln w="9525" cap="flat" cmpd="sng" algn="ctr">
-          <a:solidFill>
-            <a:schemeClr val="phClr">
-              <a:shade val="95000"/>
-              <a:satMod val="105000"/>
-            </a:schemeClr>
-          </a:solidFill>
-          <a:prstDash val="solid"/>
-        </a:ln>
-        <a:ln w="25400" cap="flat" cmpd="sng" algn="ctr">
-          <a:solidFill>
-            <a:schemeClr val="phClr"/>
-          </a:solidFill>
-          <a:prstDash val="solid"/>
-        </a:ln>
-        <a:ln w="38100" cap="flat" cmpd="sng" algn="ctr">
-          <a:solidFill>
-            <a:schemeClr val="phClr"/>
-          </a:solidFill>
-          <a:prstDash val="solid"/>
-        </a:ln>
-      </a:lnStyleLst>
-      <a:effectStyleLst>
-        <a:effectStyle>
-          <a:effectLst>
-            <a:outerShdw blurRad="40000" dist="20000" dir="5400000" rotWithShape="0">
-              <a:srgbClr val="000000">
-                <a:alpha val="38000"/>
-              </a:srgbClr>
-            </a:outerShdw>
-          </a:effectLst>
-        </a:effectStyle>
-        <a:effectStyle>
-          <a:effectLst>
-            <a:outerShdw blurRad="40000" dist="23000" dir="5400000" rotWithShape="0">
-              <a:srgbClr val="000000">
-                <a:alpha val="35000"/>
-              </a:srgbClr>
-            </a:outerShdw>
-          </a:effectLst>
-        </a:effectStyle>
-        <a:effectStyle>
-          <a:effectLst>
-            <a:outerShdw blurRad="40000" dist="23000" dir="5400000" rotWithShape="0">
-              <a:srgbClr val="000000">
-                <a:alpha val="35000"/>
-              </a:srgbClr>
-            </a:outerShdw>
-          </a:effectLst>
-          <a:scene3d>
-            <a:camera prst="orthographicFront">
-              <a:rot lat="0" lon="0" rev="0"/>
-            </a:camera>
-            <a:lightRig rig="threePt" dir="t">
-              <a:rot lat="0" lon="0" rev="1200000"/>
-            </a:lightRig>
-          </a:scene3d>
-          <a:sp3d>
-            <a:bevelT w="63500" h="25400"/>
-          </a:sp3d>
-        </a:effectStyle>
-      </a:effectStyleLst>
-      <a:bgFillStyleLst>
-        <a:solidFill>
-          <a:schemeClr val="phClr"/>
-        </a:solidFill>
-        <a:gradFill rotWithShape="1">
-          <a:gsLst>
-            <a:gs pos="0">
-              <a:schemeClr val="phClr">
-                <a:tint val="40000"/>
-                <a:satMod val="350000"/>
-              </a:schemeClr>
-            </a:gs>
-            <a:gs pos="40000">
-              <a:schemeClr val="phClr">
-                <a:tint val="45000"/>
-                <a:shade val="99000"/>
-                <a:satMod val="350000"/>
-              </a:schemeClr>
-            </a:gs>
-            <a:gs pos="100000">
-              <a:schemeClr val="phClr">
-                <a:shade val="20000"/>
-                <a:satMod val="255000"/>
-              </a:schemeClr>
-            </a:gs>
-          </a:gsLst>
-          <a:path path="circle">
-            <a:fillToRect l="50000" t="-80000" r="50000" b="180000"/>
-          </a:path>
-        </a:gradFill>
-        <a:gradFill rotWithShape="1">
-          <a:gsLst>
-            <a:gs pos="0">
-              <a:schemeClr val="phClr">
-                <a:tint val="80000"/>
-                <a:satMod val="300000"/>
-              </a:schemeClr>
-            </a:gs>
-            <a:gs pos="100000">
-              <a:schemeClr val="phClr">
-                <a:shade val="30000"/>
-                <a:satMod val="200000"/>
-              </a:schemeClr>
-            </a:gs>
-          </a:gsLst>
-          <a:path path="circle">
-            <a:fillToRect l="50000" t="50000" r="50000" b="50000"/>
-          </a:path>
-        </a:gradFill>
-      </a:bgFillStyleLst>
-    </a:fmtScheme>
-  </a:themeElements>
-</a:theme>
 </file>
</xml_diff>

<commit_message>
Finish recorded architecture demos and update presentation
</commit_message>
<xml_diff>
--- a/AI in Architecture - Presentation.pptx
+++ b/AI in Architecture - Presentation.pptx
@@ -1540,6 +1540,69 @@
               <a:spcAft>
                 <a:spcPts val="0"/>
               </a:spcAft>
+              <a:buClr>
+                <a:schemeClr val="dk1"/>
+              </a:buClr>
+              <a:buSzPts val="1100"/>
+              <a:buFont typeface="Arial"/>
+              <a:buNone/>
+            </a:pPr>
+            <a:r>
+              <a:rPr lang="en-GB"/>
+              <a:t>Demo: 02-command-selection.mp4</a:t>
+            </a:r>
+            <a:endParaRPr/>
+          </a:p>
+          <a:p>
+            <a:pPr indent="0" lvl="0" marL="0" rtl="0" algn="l">
+              <a:spcBef>
+                <a:spcPts val="0"/>
+              </a:spcBef>
+              <a:spcAft>
+                <a:spcPts val="0"/>
+              </a:spcAft>
+              <a:buClr>
+                <a:schemeClr val="dk1"/>
+              </a:buClr>
+              <a:buSzPts val="1100"/>
+              <a:buFont typeface="Arial"/>
+              <a:buNone/>
+            </a:pPr>
+            <a:r>
+              <a:rPr lang="en-GB"/>
+              <a:t>Prompt: Choose Rhino commands to make a closed rounded dome from the radial profile.</a:t>
+            </a:r>
+            <a:endParaRPr/>
+          </a:p>
+          <a:p>
+            <a:pPr indent="0" lvl="0" marL="0" rtl="0" algn="l">
+              <a:spcBef>
+                <a:spcPts val="0"/>
+              </a:spcBef>
+              <a:spcAft>
+                <a:spcPts val="0"/>
+              </a:spcAft>
+              <a:buClr>
+                <a:schemeClr val="dk1"/>
+              </a:buClr>
+              <a:buSzPts val="1100"/>
+              <a:buFont typeface="Arial"/>
+              <a:buNone/>
+            </a:pPr>
+            <a:r>
+              <a:rPr lang="en-GB"/>
+              <a:t>The recording runs Revolve about World Z, FullCircle, Cap and Check. The saved result is one valid closed Brep with two faces. The profile and result are in 02-command-selection.3dm.</a:t>
+            </a:r>
+            <a:endParaRPr/>
+          </a:p>
+          <a:p>
+            <a:pPr indent="0" lvl="0" marL="0" rtl="0" algn="l">
+              <a:spcBef>
+                <a:spcPts val="0"/>
+              </a:spcBef>
+              <a:spcAft>
+                <a:spcPts val="0"/>
+              </a:spcAft>
               <a:buNone/>
             </a:pPr>
             <a:r>
@@ -1639,6 +1702,90 @@
               <a:spcAft>
                 <a:spcPts val="0"/>
               </a:spcAft>
+              <a:buClr>
+                <a:schemeClr val="dk1"/>
+              </a:buClr>
+              <a:buSzPts val="1100"/>
+              <a:buFont typeface="Arial"/>
+              <a:buNone/>
+            </a:pPr>
+            <a:r>
+              <a:rPr lang="en-GB"/>
+              <a:t>Demo: 03-habitat-prompt.mp4</a:t>
+            </a:r>
+            <a:endParaRPr/>
+          </a:p>
+          <a:p>
+            <a:pPr indent="0" lvl="0" marL="0" rtl="0" algn="l">
+              <a:spcBef>
+                <a:spcPts val="0"/>
+              </a:spcBef>
+              <a:spcAft>
+                <a:spcPts val="0"/>
+              </a:spcAft>
+              <a:buClr>
+                <a:schemeClr val="dk1"/>
+              </a:buClr>
+              <a:buSzPts val="1100"/>
+              <a:buFont typeface="Arial"/>
+              <a:buNone/>
+            </a:pPr>
+            <a:r>
+              <a:rPr lang="en-GB"/>
+              <a:t>Prompt: Build Habitat 67.</a:t>
+            </a:r>
+            <a:endParaRPr/>
+          </a:p>
+          <a:p>
+            <a:pPr indent="0" lvl="0" marL="0" rtl="0" algn="l">
+              <a:spcBef>
+                <a:spcPts val="0"/>
+              </a:spcBef>
+              <a:spcAft>
+                <a:spcPts val="0"/>
+              </a:spcAft>
+              <a:buClr>
+                <a:schemeClr val="dk1"/>
+              </a:buClr>
+              <a:buSzPts val="1100"/>
+              <a:buFont typeface="Arial"/>
+              <a:buNone/>
+            </a:pPr>
+            <a:r>
+              <a:rPr lang="en-GB"/>
+              <a:t>The script builds an approximate stepped massing study from raw mesh coordinates. It contains 126 assumed modules, 1,008 vertices and 756 quad faces. Rhino reports a valid closed mesh. Dimensions and arrangement are assumptions. The result does not reconstruct the original plans or demonstrate architectural fidelity.</a:t>
+            </a:r>
+            <a:endParaRPr/>
+          </a:p>
+          <a:p>
+            <a:pPr indent="0" lvl="0" marL="0" rtl="0" algn="l">
+              <a:spcBef>
+                <a:spcPts val="0"/>
+              </a:spcBef>
+              <a:spcAft>
+                <a:spcPts val="0"/>
+              </a:spcAft>
+              <a:buClr>
+                <a:schemeClr val="dk1"/>
+              </a:buClr>
+              <a:buSzPts val="1100"/>
+              <a:buFont typeface="Arial"/>
+              <a:buNone/>
+            </a:pPr>
+            <a:r>
+              <a:rPr lang="en-GB"/>
+              <a:t>Reference: https://www.safdiearchitects.com/projects/habitat-67</a:t>
+            </a:r>
+            <a:endParaRPr/>
+          </a:p>
+          <a:p>
+            <a:pPr indent="0" lvl="0" marL="0" rtl="0" algn="l">
+              <a:spcBef>
+                <a:spcPts val="0"/>
+              </a:spcBef>
+              <a:spcAft>
+                <a:spcPts val="0"/>
+              </a:spcAft>
               <a:buNone/>
             </a:pPr>
             <a:r>
@@ -1741,7 +1888,40 @@
               <a:buNone/>
             </a:pPr>
             <a:r>
-              <a:t/>
+              <a:rPr lang="en-GB"/>
+              <a:t>Demo: 04-parametric-tower.mp4</a:t>
+            </a:r>
+            <a:endParaRPr/>
+          </a:p>
+          <a:p>
+            <a:pPr indent="0" lvl="0" marL="0" rtl="0" algn="l">
+              <a:spcBef>
+                <a:spcPts val="0"/>
+              </a:spcBef>
+              <a:spcAft>
+                <a:spcPts val="0"/>
+              </a:spcAft>
+              <a:buNone/>
+            </a:pPr>
+            <a:r>
+              <a:rPr lang="en-GB"/>
+              <a:t>Prompt: Create a tower with floor-count and twist controls. Use 12 square slabs, 3.2 m storey height and a central core.</a:t>
+            </a:r>
+            <a:endParaRPr/>
+          </a:p>
+          <a:p>
+            <a:pPr indent="0" lvl="0" marL="0" rtl="0" algn="l">
+              <a:spcBef>
+                <a:spcPts val="0"/>
+              </a:spcBef>
+              <a:spcAft>
+                <a:spcPts val="0"/>
+              </a:spcAft>
+              <a:buNone/>
+            </a:pPr>
+            <a:r>
+              <a:rPr lang="en-GB"/>
+              <a:t>The Python component runs inside Grasshopper. The recording changes total twist from 0 to 60 degrees. Both exports contain 12 valid closed slab solids and one valid closed core. Structure and circulation are outside this geometry study.</a:t>
             </a:r>
             <a:endParaRPr/>
           </a:p>
@@ -1837,11 +2017,136 @@
               <a:spcAft>
                 <a:spcPts val="0"/>
               </a:spcAft>
+              <a:buClr>
+                <a:schemeClr val="dk1"/>
+              </a:buClr>
+              <a:buSzPts val="1100"/>
+              <a:buFont typeface="Arial"/>
               <a:buNone/>
             </a:pPr>
             <a:r>
               <a:rPr lang="en-GB"/>
-              <a:t>Source: https://github.com/jviquerat/lbm, commit 64023fc76db2ddb681b2d4d24306a433e85f9555 (MIT, Jonathan Viquerat). Adapt the existing D2Q9/TRT code into a Grasshopper Python 3 tool. Replace Numba decorators with NumPy; keep the numerical routines. Rasterise closed footprints on a 160 x 64 grid. Solve 1800 steps, then move the middle block by -12 lattice units and solve again. OBS video: 05-lbm-to-grasshopper.mp4. The code, GH definition, two output models and checks are at the repo root. Both runs have finite populations and positive density. Colour shows speed relative to inlet peak; line segments show local velocity direction. This is a 2D laminar channel in lattice units. It omits vertical flow and atmospheric boundary conditions; grid convergence and physical accuracy have not been assessed.</a:t>
+              <a:t>Demo: 05-lbm-to-grasshopper.mp4</a:t>
+            </a:r>
+            <a:endParaRPr/>
+          </a:p>
+          <a:p>
+            <a:pPr indent="0" lvl="0" marL="0" rtl="0" algn="l">
+              <a:spcBef>
+                <a:spcPts val="0"/>
+              </a:spcBef>
+              <a:spcAft>
+                <a:spcPts val="0"/>
+              </a:spcAft>
+              <a:buClr>
+                <a:schemeClr val="dk1"/>
+              </a:buClr>
+              <a:buSzPts val="1100"/>
+              <a:buFont typeface="Arial"/>
+              <a:buNone/>
+            </a:pPr>
+            <a:r>
+              <a:rPr lang="en-GB"/>
+              <a:t>Prompt: Adapt the D2Q9/TRT numerical routines in github.com/jviquerat/lbm into a Grasshopper Python tool. Convert closed building footprints into obstacles. Solve a horizontal 2D slice, then move one footprint and solve again.</a:t>
+            </a:r>
+            <a:endParaRPr/>
+          </a:p>
+          <a:p>
+            <a:pPr indent="0" lvl="0" marL="0" rtl="0" algn="l">
+              <a:spcBef>
+                <a:spcPts val="0"/>
+              </a:spcBef>
+              <a:spcAft>
+                <a:spcPts val="0"/>
+              </a:spcAft>
+              <a:buClr>
+                <a:schemeClr val="dk1"/>
+              </a:buClr>
+              <a:buSzPts val="1100"/>
+              <a:buFont typeface="Arial"/>
+              <a:buNone/>
+            </a:pPr>
+            <a:r>
+              <a:rPr lang="en-GB"/>
+              <a:t>Source: https://github.com/jviquerat/lbm commit 64023fc76db2ddb681b2d4d24306a433e85f9555. MIT licence, Jonathan Viquerat. The port removes Numba decorators and keeps the numerical formulas.</a:t>
+            </a:r>
+            <a:endParaRPr/>
+          </a:p>
+          <a:p>
+            <a:pPr indent="0" lvl="0" marL="0" rtl="0" algn="l">
+              <a:spcBef>
+                <a:spcPts val="0"/>
+              </a:spcBef>
+              <a:spcAft>
+                <a:spcPts val="0"/>
+              </a:spcAft>
+              <a:buClr>
+                <a:schemeClr val="dk1"/>
+              </a:buClr>
+              <a:buSzPts val="1100"/>
+              <a:buFont typeface="Arial"/>
+              <a:buNone/>
+            </a:pPr>
+            <a:r>
+              <a:rPr lang="en-GB"/>
+              <a:t>Grid 160 x 64. 1,800 steps. Inlet peak 0.03 lattice units. Middle block shift 0 to -12 changes peak speed from 0.05592 to 0.04986. Both runs have finite values and positive density.</a:t>
+            </a:r>
+            <a:endParaRPr/>
+          </a:p>
+          <a:p>
+            <a:pPr indent="0" lvl="0" marL="0" rtl="0" algn="l">
+              <a:spcBef>
+                <a:spcPts val="0"/>
+              </a:spcBef>
+              <a:spcAft>
+                <a:spcPts val="0"/>
+              </a:spcAft>
+              <a:buClr>
+                <a:schemeClr val="dk1"/>
+              </a:buClr>
+              <a:buSzPts val="1100"/>
+              <a:buFont typeface="Arial"/>
+              <a:buNone/>
+            </a:pPr>
+            <a:r>
+              <a:rPr lang="en-GB"/>
+              <a:t>This is a 2D laminar channel teaching model in lattice units. Physical accuracy and grid convergence have not been assessed. Vertical flow and atmospheric boundary conditions are omitted.</a:t>
+            </a:r>
+            <a:endParaRPr/>
+          </a:p>
+          <a:p>
+            <a:pPr indent="0" lvl="0" marL="0" rtl="0" algn="l">
+              <a:spcBef>
+                <a:spcPts val="0"/>
+              </a:spcBef>
+              <a:spcAft>
+                <a:spcPts val="0"/>
+              </a:spcAft>
+              <a:buClr>
+                <a:schemeClr val="dk1"/>
+              </a:buClr>
+              <a:buSzPts val="1100"/>
+              <a:buFont typeface="Arial"/>
+              <a:buNone/>
+            </a:pPr>
+            <a:r>
+              <a:rPr lang="en-GB"/>
+              <a:t>Teaching point: students can find relevant source code, inspect its assumptions, adapt its inputs and outputs, then test the tool in their design environment.</a:t>
+            </a:r>
+            <a:endParaRPr/>
+          </a:p>
+          <a:p>
+            <a:pPr indent="0" lvl="0" marL="0" rtl="0" algn="l">
+              <a:spcBef>
+                <a:spcPts val="0"/>
+              </a:spcBef>
+              <a:spcAft>
+                <a:spcPts val="0"/>
+              </a:spcAft>
+              <a:buNone/>
+            </a:pPr>
+            <a:r>
+              <a:t/>
             </a:r>
             <a:endParaRPr/>
           </a:p>
@@ -2039,7 +2344,88 @@
               <a:buNone/>
             </a:pPr>
             <a:r>
-              <a:t/>
+              <a:rPr lang="en-GB"/>
+              <a:t>Demo: 20-toronto-zoning.mp4</a:t>
+            </a:r>
+            <a:endParaRPr/>
+          </a:p>
+          <a:p>
+            <a:pPr indent="0" lvl="0" marL="0" rtl="0" algn="l">
+              <a:spcBef>
+                <a:spcPts val="0"/>
+              </a:spcBef>
+              <a:spcAft>
+                <a:spcPts val="0"/>
+              </a:spcAft>
+              <a:buNone/>
+            </a:pPr>
+            <a:r>
+              <a:rPr lang="en-GB"/>
+              <a:t>Fictional teaching lot: RD(f15)(d0.6), width 15 m, depth 36 m, then 30 m. Detached house without a secondary suite. No real address or mapped overlay has been checked.</a:t>
+            </a:r>
+            <a:endParaRPr/>
+          </a:p>
+          <a:p>
+            <a:pPr indent="0" lvl="0" marL="0" rtl="0" algn="l">
+              <a:spcBef>
+                <a:spcPts val="0"/>
+              </a:spcBef>
+              <a:spcAft>
+                <a:spcPts val="0"/>
+              </a:spcAft>
+              <a:buNone/>
+            </a:pPr>
+            <a:r>
+              <a:rPr lang="en-GB"/>
+              <a:t>Source: https://www.toronto.ca/zoning/bylaw_amendments/ZBL_NewProvision_Chapter10_20.htm</a:t>
+            </a:r>
+            <a:endParaRPr/>
+          </a:p>
+          <a:p>
+            <a:pPr indent="0" lvl="0" marL="0" rtl="0" algn="l">
+              <a:spcBef>
+                <a:spcPts val="0"/>
+              </a:spcBef>
+              <a:spcAft>
+                <a:spcPts val="0"/>
+              </a:spcAft>
+              <a:buNone/>
+            </a:pPr>
+            <a:r>
+              <a:rPr lang="en-GB"/>
+              <a:t>Selected clauses: 10.20.30.10 minimum lot area 450 m2. 10.20.40.70 front setback 6 m where front-yard averaging does not apply, side 1.5 m, rear greater of 7.5 m or 25% of depth. 10.20.40.20 length 17 m for required frontage up to 18 m. 10.20.40.10 height 10 m without HT and flat-roof main wall 7.5 m. FSI 0.6 follows the assumed zone label. Coverage 35% is an assumption.</a:t>
+            </a:r>
+            <a:endParaRPr/>
+          </a:p>
+          <a:p>
+            <a:pPr indent="0" lvl="0" marL="0" rtl="0" algn="l">
+              <a:spcBef>
+                <a:spcPts val="0"/>
+              </a:spcBef>
+              <a:spcAft>
+                <a:spcPts val="0"/>
+              </a:spcAft>
+              <a:buNone/>
+            </a:pPr>
+            <a:r>
+              <a:rPr lang="en-GB"/>
+              <a:t>At 36 m depth, rear setback is 9 m and the two-storey example has 324 m2 floor area. At 30 m depth, rear setback is 7.5 m and floor area is 270 m2.</a:t>
+            </a:r>
+            <a:endParaRPr/>
+          </a:p>
+          <a:p>
+            <a:pPr indent="0" lvl="0" marL="0" rtl="0" algn="l">
+              <a:spcBef>
+                <a:spcPts val="0"/>
+              </a:spcBef>
+              <a:spcAft>
+                <a:spcPts val="0"/>
+              </a:spcAft>
+              <a:buNone/>
+            </a:pPr>
+            <a:r>
+              <a:rPr lang="en-GB"/>
+              <a:t>The bounding volume is a simplified representation of selected rules. This example excludes full zoning review, overlays, exceptions and Ontario Building Code compliance. See SOURCES.md for all assumptions.</a:t>
             </a:r>
             <a:endParaRPr/>
           </a:p>
@@ -2138,7 +2524,72 @@
               <a:buNone/>
             </a:pPr>
             <a:r>
-              <a:t/>
+              <a:rPr lang="en-GB"/>
+              <a:t>Published example: 21-autodesk-published-demo.mp4</a:t>
+            </a:r>
+            <a:endParaRPr/>
+          </a:p>
+          <a:p>
+            <a:pPr indent="0" lvl="0" marL="0" rtl="0" algn="l">
+              <a:spcBef>
+                <a:spcPts val="0"/>
+              </a:spcBef>
+              <a:spcAft>
+                <a:spcPts val="0"/>
+              </a:spcAft>
+              <a:buNone/>
+            </a:pPr>
+            <a:r>
+              <a:rPr lang="en-GB"/>
+              <a:t>This clip is an OBS capture of a short excerpt from Autodesk's published Building Layout Explorer demonstration. It has not been run independently in a local Forma account.</a:t>
+            </a:r>
+            <a:endParaRPr/>
+          </a:p>
+          <a:p>
+            <a:pPr indent="0" lvl="0" marL="0" rtl="0" algn="l">
+              <a:spcBef>
+                <a:spcPts val="0"/>
+              </a:spcBef>
+              <a:spcAft>
+                <a:spcPts val="0"/>
+              </a:spcAft>
+              <a:buNone/>
+            </a:pPr>
+            <a:r>
+              <a:rPr lang="en-GB"/>
+              <a:t>Source: Autodesk News, 2 June 2026, https://adsknews.autodesk.com/en/news/building-layout-explorer-in-autodesk-forma/</a:t>
+            </a:r>
+            <a:endParaRPr/>
+          </a:p>
+          <a:p>
+            <a:pPr indent="0" lvl="0" marL="0" rtl="0" algn="l">
+              <a:spcBef>
+                <a:spcPts val="0"/>
+              </a:spcBef>
+              <a:spcAft>
+                <a:spcPts val="0"/>
+              </a:spcAft>
+              <a:buNone/>
+            </a:pPr>
+            <a:r>
+              <a:rPr lang="en-GB"/>
+              <a:t>Autodesk describes an experimental feature for commercial Forma Site Design projects stored in the US. Inputs include building massing, type and material. The feature generates floor-plan options. The source supports this narrower description, rather than an LOD 200 BIM claim.</a:t>
+            </a:r>
+            <a:endParaRPr/>
+          </a:p>
+          <a:p>
+            <a:pPr indent="0" lvl="0" marL="0" rtl="0" algn="l">
+              <a:spcBef>
+                <a:spcPts val="0"/>
+              </a:spcBef>
+              <a:spcAft>
+                <a:spcPts val="0"/>
+              </a:spcAft>
+              <a:buNone/>
+            </a:pPr>
+            <a:r>
+              <a:rPr lang="en-GB"/>
+              <a:t>The keynote link on this slide is an additional Autodesk reference. Play the local excerpt for the floor-plan example.</a:t>
             </a:r>
             <a:endParaRPr/>
           </a:p>
@@ -24477,7 +24928,19 @@
                     <a:cs typeface="Inter"/>
                     <a:sym typeface="Inter"/>
                   </a:rPr>
-                  <a:t> Profile Curves</a:t>
+                  <a:t> </a:t>
+                </a:r>
+                <a:r>
+                  <a:rPr lang="en-GB" sz="1050">
+                    <a:solidFill>
+                      <a:srgbClr val="111315"/>
+                    </a:solidFill>
+                    <a:latin typeface="Inter"/>
+                    <a:ea typeface="Inter"/>
+                    <a:cs typeface="Inter"/>
+                    <a:sym typeface="Inter"/>
+                  </a:rPr>
+                  <a:t>Radial Profile</a:t>
                 </a:r>
                 <a:endParaRPr b="0" sz="1050">
                   <a:solidFill>
@@ -24521,7 +24984,19 @@
                     <a:cs typeface="Inter"/>
                     <a:sym typeface="Inter"/>
                   </a:rPr>
-                  <a:t> Rail Revolve</a:t>
+                  <a:t> </a:t>
+                </a:r>
+                <a:r>
+                  <a:rPr lang="en-GB" sz="1050">
+                    <a:solidFill>
+                      <a:srgbClr val="111315"/>
+                    </a:solidFill>
+                    <a:latin typeface="Inter"/>
+                    <a:ea typeface="Inter"/>
+                    <a:cs typeface="Inter"/>
+                    <a:sym typeface="Inter"/>
+                  </a:rPr>
+                  <a:t>Revolve</a:t>
                 </a:r>
                 <a:endParaRPr b="0" sz="1050">
                   <a:solidFill>
@@ -24565,7 +25040,19 @@
                     <a:cs typeface="Inter"/>
                     <a:sym typeface="Inter"/>
                   </a:rPr>
-                  <a:t> Rebuild</a:t>
+                  <a:t> </a:t>
+                </a:r>
+                <a:r>
+                  <a:rPr lang="en-GB" sz="1050">
+                    <a:solidFill>
+                      <a:srgbClr val="111315"/>
+                    </a:solidFill>
+                    <a:latin typeface="Inter"/>
+                    <a:ea typeface="Inter"/>
+                    <a:cs typeface="Inter"/>
+                    <a:sym typeface="Inter"/>
+                  </a:rPr>
+                  <a:t>Cap</a:t>
                 </a:r>
                 <a:endParaRPr b="0" sz="1050">
                   <a:solidFill>
@@ -24609,7 +25096,19 @@
                     <a:cs typeface="Inter"/>
                     <a:sym typeface="Inter"/>
                   </a:rPr>
-                  <a:t> FlowAlongSrf</a:t>
+                  <a:t> </a:t>
+                </a:r>
+                <a:r>
+                  <a:rPr lang="en-GB" sz="1050">
+                    <a:solidFill>
+                      <a:srgbClr val="111315"/>
+                    </a:solidFill>
+                    <a:latin typeface="Inter"/>
+                    <a:ea typeface="Inter"/>
+                    <a:cs typeface="Inter"/>
+                    <a:sym typeface="Inter"/>
+                  </a:rPr>
+                  <a:t>Check</a:t>
                 </a:r>
                 <a:endParaRPr b="0" sz="1050">
                   <a:solidFill>
@@ -25357,7 +25856,7 @@
               <a:buNone/>
             </a:pPr>
             <a:r>
-              <a:rPr b="1" i="0" lang="en-GB" sz="1050" u="none" strike="noStrike">
+              <a:rPr b="1" lang="en-GB" sz="1050">
                 <a:solidFill>
                   <a:srgbClr val="D9381E"/>
                 </a:solidFill>
@@ -25366,7 +25865,7 @@
                 <a:cs typeface="Inter"/>
                 <a:sym typeface="Inter"/>
               </a:rPr>
-              <a:t>Irregular 3D Mesh Output</a:t>
+              <a:t>Generated Mesh Checks</a:t>
             </a:r>
             <a:endParaRPr b="1" i="0" sz="1050" u="none" strike="noStrike">
               <a:solidFill>
@@ -25418,7 +25917,7 @@
               <a:buNone/>
             </a:pPr>
             <a:r>
-              <a:rPr b="0" i="0" lang="en-GB" sz="893" u="none" strike="noStrike">
+              <a:rPr lang="en-GB" sz="893">
                 <a:solidFill>
                   <a:srgbClr val="D9381E"/>
                 </a:solidFill>
@@ -25427,7 +25926,7 @@
                 <a:cs typeface="Inter"/>
                 <a:sym typeface="Inter"/>
               </a:rPr>
-              <a:t>• Generating raw 3D mesh vertex coordinates directly from text models results in irregular geometry.</a:t>
+              <a:t>• This run produces 126 assumed modules in one closed mesh.</a:t>
             </a:r>
             <a:endParaRPr b="0" i="0" sz="893" u="none" strike="noStrike">
               <a:solidFill>
@@ -25453,7 +25952,7 @@
               <a:buNone/>
             </a:pPr>
             <a:r>
-              <a:rPr b="0" i="0" lang="en-GB" sz="893" u="none" strike="noStrike">
+              <a:rPr lang="en-GB" sz="893">
                 <a:solidFill>
                   <a:srgbClr val="D9381E"/>
                 </a:solidFill>
@@ -25462,7 +25961,7 @@
                 <a:cs typeface="Inter"/>
                 <a:sym typeface="Inter"/>
               </a:rPr>
-              <a:t>• Language models do not contain internal 3D geometric constraints for architectural construction.</a:t>
+              <a:t>• Module dimensions and the stepped layout are assumptions.</a:t>
             </a:r>
             <a:endParaRPr b="0" i="0" sz="893" u="none" strike="noStrike">
               <a:solidFill>
@@ -25488,7 +25987,7 @@
               <a:buNone/>
             </a:pPr>
             <a:r>
-              <a:rPr b="0" i="0" lang="en-GB" sz="893" u="none" strike="noStrike">
+              <a:rPr lang="en-GB" sz="893">
                 <a:solidFill>
                   <a:srgbClr val="D9381E"/>
                 </a:solidFill>
@@ -25497,7 +25996,7 @@
                 <a:cs typeface="Inter"/>
                 <a:sym typeface="Inter"/>
               </a:rPr>
-              <a:t>• Direct numerical coordinate generation does not guarantee topological consistency.</a:t>
+              <a:t>• A valid mesh still needs comparison with the building.</a:t>
             </a:r>
             <a:endParaRPr b="0" i="0" sz="893" u="none" strike="noStrike">
               <a:solidFill>
@@ -25692,7 +26191,7 @@
                 <a:buNone/>
               </a:pPr>
               <a:r>
-                <a:rPr b="0" i="0" lang="en-GB" sz="750" u="none" strike="noStrike">
+                <a:rPr lang="en-GB" sz="750">
                   <a:solidFill>
                     <a:srgbClr val="111315"/>
                   </a:solidFill>
@@ -25701,7 +26200,7 @@
                   <a:cs typeface="JetBrains Mono"/>
                   <a:sym typeface="JetBrains Mono"/>
                 </a:rPr>
-                <a:t>[Demonstration 1B: Direct Mesh Generation]</a:t>
+                <a:t>OBS demo: 03-habitat-prompt.mp4</a:t>
               </a:r>
               <a:endParaRPr b="0" i="0" sz="750" u="none" strike="noStrike">
                 <a:solidFill>
@@ -25751,7 +26250,7 @@
               <a:buNone/>
             </a:pPr>
             <a:r>
-              <a:rPr b="0" lang="en-GB" sz="750">
+              <a:rPr lang="en-GB" sz="750">
                 <a:solidFill>
                   <a:srgbClr val="5A626A"/>
                 </a:solidFill>
@@ -25760,7 +26259,7 @@
                 <a:cs typeface="JetBrains Mono"/>
                 <a:sym typeface="JetBrains Mono"/>
               </a:rPr>
-              <a:t>Ref: Safdie (1967); Gaudi (1882).</a:t>
+              <a:t>Reference: Safdie Architects, Habitat 67. Approximate massing.</a:t>
             </a:r>
             <a:endParaRPr b="0" sz="750">
               <a:solidFill>
@@ -26065,7 +26564,7 @@
                   <a:cs typeface="JetBrains Mono"/>
                   <a:sym typeface="JetBrains Mono"/>
                 </a:rPr>
-                <a:t>[Prompt]</a:t>
+                <a:t>Create a tower with floor-count and twist controls.</a:t>
               </a:r>
               <a:endParaRPr b="1" sz="825">
                 <a:solidFill>
@@ -26278,7 +26777,7 @@
                 <a:buNone/>
               </a:pPr>
               <a:r>
-                <a:rPr b="1" i="0" lang="en-GB" sz="975" u="none" strike="noStrike">
+                <a:rPr b="1" lang="en-GB" sz="975">
                   <a:solidFill>
                     <a:srgbClr val="1D4ED8"/>
                   </a:solidFill>
@@ -26287,7 +26786,7 @@
                   <a:cs typeface="Inter"/>
                   <a:sym typeface="Inter"/>
                 </a:rPr>
-                <a:t>[Model writes Python or C# Grasshopper component]</a:t>
+                <a:t>Python component in Grasshopper</a:t>
               </a:r>
               <a:endParaRPr b="1" i="0" sz="975" u="none" strike="noStrike">
                 <a:solidFill>
@@ -26509,7 +27008,7 @@
                   <a:cs typeface="JetBrains Mono"/>
                   <a:sym typeface="JetBrains Mono"/>
                 </a:rPr>
-                <a:t>[Parametric Geometry]</a:t>
+                <a:t>12 closed slabs and one core</a:t>
               </a:r>
               <a:endParaRPr b="1" sz="825">
                 <a:solidFill>
@@ -26865,7 +27364,7 @@
                 <a:buNone/>
               </a:pPr>
               <a:r>
-                <a:rPr b="1" i="0" lang="en-GB" sz="825" u="none" strike="noStrike">
+                <a:rPr b="1" lang="en-GB" sz="825">
                   <a:solidFill>
                     <a:srgbClr val="111315"/>
                   </a:solidFill>
@@ -26874,7 +27373,7 @@
                   <a:cs typeface="JetBrains Mono"/>
                   <a:sym typeface="JetBrains Mono"/>
                 </a:rPr>
-                <a:t>[Demonstration 2A: Grasshopper Script Execution]</a:t>
+                <a:t>OBS demo: 04-parametric-tower.mp4</a:t>
               </a:r>
               <a:endParaRPr b="1" i="0" sz="825" u="none" strike="noStrike">
                 <a:solidFill>
@@ -27131,7 +27630,7 @@
                   <a:cs typeface="Space Grotesk SemiBold"/>
                   <a:sym typeface="Space Grotesk SemiBold"/>
                 </a:rPr>
-                <a:t>A small lattice Boltzmann solver shows flow around building footprints in a horizontal slice.</a:t>
+                <a:t>Adapt existing LBM code into a Grasshopper tool for a 2D flow slice.</a:t>
               </a:r>
               <a:endParaRPr b="0" i="0" sz="1125" u="none" strike="noStrike">
                 <a:solidFill>
@@ -27636,7 +28135,7 @@
                 <a:buNone/>
               </a:pPr>
               <a:r>
-                <a:rPr b="1" i="0" lang="en-GB" sz="750" u="none" strike="noStrike">
+                <a:rPr b="1" lang="en-GB" sz="750">
                   <a:solidFill>
                     <a:srgbClr val="111315"/>
                   </a:solidFill>
@@ -27645,7 +28144,7 @@
                   <a:cs typeface="JetBrains Mono"/>
                   <a:sym typeface="JetBrains Mono"/>
                 </a:rPr>
-                <a:t>02 // CODE GENERATION</a:t>
+                <a:t>02 // CODE ADAPTATION</a:t>
               </a:r>
               <a:endParaRPr b="1" i="0" sz="750" u="none" strike="noStrike">
                 <a:solidFill>
@@ -29408,7 +29907,7 @@
                     <a:cs typeface="Inter"/>
                     <a:sym typeface="Inter"/>
                   </a:rPr>
-                  <a:t>Municipal Zoning Text</a:t>
+                  <a:t>Toronto RD Zoning Rules</a:t>
                 </a:r>
                 <a:endParaRPr b="1" sz="1050">
                   <a:solidFill>
@@ -29431,7 +29930,7 @@
                   <a:buNone/>
                 </a:pPr>
                 <a:r>
-                  <a:rPr b="0" lang="en-GB" sz="750">
+                  <a:rPr lang="en-GB" sz="750">
                     <a:solidFill>
                       <a:srgbClr val="5A626A"/>
                     </a:solidFill>
@@ -29440,7 +29939,7 @@
                     <a:cs typeface="JetBrains Mono"/>
                     <a:sym typeface="JetBrains Mono"/>
                   </a:rPr>
-                  <a:t>Raw zoning ordinances, land-use bylaws, and building code documentation.</a:t>
+                  <a:t>Selected Toronto clauses. Fictional 15 x 36 m lot.</a:t>
                 </a:r>
                 <a:endParaRPr b="0" sz="750">
                   <a:solidFill>
@@ -29754,7 +30253,7 @@
                   <a:buNone/>
                 </a:pPr>
                 <a:r>
-                  <a:rPr b="0" i="0" lang="en-GB" sz="975" u="none" strike="noStrike">
+                  <a:rPr lang="en-GB" sz="975">
                     <a:solidFill>
                       <a:srgbClr val="111315"/>
                     </a:solidFill>
@@ -29763,7 +30262,7 @@
                     <a:cs typeface="Inter"/>
                     <a:sym typeface="Inter"/>
                   </a:rPr>
-                  <a:t>The model extracts numeric values for setbacks, stepbacks, and maximum height limits.</a:t>
+                  <a:t>Check each clause. Declare the zone, setbacks and coverage assumptions.</a:t>
                 </a:r>
                 <a:endParaRPr b="0" i="0" sz="750" u="none" strike="noStrike">
                   <a:solidFill>
@@ -30077,7 +30576,7 @@
                   <a:buNone/>
                 </a:pPr>
                 <a:r>
-                  <a:rPr b="0" i="0" lang="en-GB" sz="750" u="none" strike="noStrike">
+                  <a:rPr lang="en-GB" sz="750">
                     <a:solidFill>
                       <a:srgbClr val="5A626A"/>
                     </a:solidFill>
@@ -30086,7 +30585,7 @@
                     <a:cs typeface="JetBrains Mono"/>
                     <a:sym typeface="JetBrains Mono"/>
                   </a:rPr>
-                  <a:t>Constructs the parametric 3D boundary volume from extracted dimensions.</a:t>
+                  <a:t>Change lot depth to 30 m. Recompute setbacks and house size.</a:t>
                 </a:r>
                 <a:endParaRPr b="0" i="0" sz="750" u="none" strike="noStrike">
                   <a:solidFill>
@@ -30595,7 +31094,7 @@
               <a:buNone/>
             </a:pPr>
             <a:r>
-              <a:rPr b="1" i="0" lang="en-GB" sz="1950" u="none" strike="noStrike">
+              <a:rPr b="1" lang="en-GB" sz="1950">
                 <a:solidFill>
                   <a:srgbClr val="111315"/>
                 </a:solidFill>
@@ -30604,7 +31103,7 @@
                 <a:cs typeface="Space Grotesk"/>
                 <a:sym typeface="Space Grotesk"/>
               </a:rPr>
-              <a:t>System Example 3: Autodesk AEC Foundation Models</a:t>
+              <a:t>System Example 3: Autodesk Forma (Published Demo)</a:t>
             </a:r>
             <a:endParaRPr b="1" i="0" sz="1950" u="none" strike="noStrike">
               <a:solidFill>
@@ -30725,7 +31224,7 @@
                   <a:cs typeface="Inter"/>
                   <a:sym typeface="Inter"/>
                 </a:rPr>
-                <a:t>Structured CAD/BIM Topology &amp; Constraints</a:t>
+                <a:t>Building massing, type and material</a:t>
               </a:r>
               <a:endParaRPr/>
             </a:p>
@@ -30839,7 +31338,7 @@
                   <a:cs typeface="Inter"/>
                   <a:sym typeface="Inter"/>
                 </a:rPr>
-                <a:t>AEC Foundation Model</a:t>
+                <a:t>Forma Building Layout Explorer</a:t>
               </a:r>
               <a:endParaRPr/>
             </a:p>
@@ -30953,7 +31452,7 @@
                   <a:cs typeface="Inter"/>
                   <a:sym typeface="Inter"/>
                 </a:rPr>
-                <a:t>Editable LOD 200 BIM Geometry</a:t>
+                <a:t>Floor-plan options (experimental)</a:t>
               </a:r>
               <a:endParaRPr/>
             </a:p>

</xml_diff>